<commit_message>
add animations to confusion slide
</commit_message>
<xml_diff>
--- a/presentation/prompt-engineering-content.pptx
+++ b/presentation/prompt-engineering-content.pptx
@@ -14386,7 +14386,7 @@
               <a:buNone/>
             </a:pPr>
             <a:r>
-              <a:rPr lang="en-US" sz="1300" b="1"/>
+              <a:rPr lang="en-US" sz="1300" b="1" dirty="0"/>
               <a:t>Illusion of Reasoning</a:t>
             </a:r>
           </a:p>
@@ -14395,7 +14395,7 @@
               <a:buNone/>
             </a:pPr>
             <a:r>
-              <a:rPr lang="en-US" sz="1300"/>
+              <a:rPr lang="en-US" sz="1300" dirty="0"/>
               <a:t>LLMs generate responses that seem intelligent but do not reflect true understanding.</a:t>
             </a:r>
           </a:p>
@@ -14407,7 +14407,7 @@
               <a:buNone/>
             </a:pPr>
             <a:r>
-              <a:rPr lang="en-US" sz="1300" b="1"/>
+              <a:rPr lang="en-US" sz="1300" b="1" dirty="0"/>
               <a:t>Hallucination with Authority</a:t>
             </a:r>
           </a:p>
@@ -14416,7 +14416,7 @@
               <a:buNone/>
             </a:pPr>
             <a:r>
-              <a:rPr lang="en-US" sz="1300"/>
+              <a:rPr lang="en-US" sz="1300" dirty="0"/>
               <a:t>LLMs can and do present invented facts, citations, and data with confidence.  They do not internally distinguish between accurate and fabricated information.</a:t>
             </a:r>
           </a:p>
@@ -14428,7 +14428,7 @@
               <a:buNone/>
             </a:pPr>
             <a:r>
-              <a:rPr lang="en-US" sz="1300" b="1"/>
+              <a:rPr lang="en-US" sz="1300" b="1" dirty="0"/>
               <a:t>Contextual Amnesia</a:t>
             </a:r>
           </a:p>
@@ -14437,7 +14437,7 @@
               <a:buNone/>
             </a:pPr>
             <a:r>
-              <a:rPr lang="en-US" sz="1300"/>
+              <a:rPr lang="en-US" sz="1300" dirty="0"/>
               <a:t>LLMs, with some exceptions, cannot learn from previous conversations.  Limited context windows create “forgetting” mid-conversation.</a:t>
             </a:r>
           </a:p>
@@ -14449,7 +14449,7 @@
               <a:buNone/>
             </a:pPr>
             <a:r>
-              <a:rPr lang="en-US" sz="1300" b="1"/>
+              <a:rPr lang="en-US" sz="1300" b="1" dirty="0"/>
               <a:t>Inconsistent Expertise</a:t>
             </a:r>
           </a:p>
@@ -14458,7 +14458,7 @@
               <a:buNone/>
             </a:pPr>
             <a:r>
-              <a:rPr lang="en-US" sz="1300"/>
+              <a:rPr lang="en-US" sz="1300" dirty="0"/>
               <a:t>LLMs sometimes excel at complex tasks while failing hilariously at simple ones.  They also provide different responses to identical questions asked differently.</a:t>
             </a:r>
           </a:p>
@@ -14470,7 +14470,7 @@
               <a:buNone/>
             </a:pPr>
             <a:r>
-              <a:rPr lang="en-US" sz="1300" b="1"/>
+              <a:rPr lang="en-US" sz="1300" b="1" dirty="0"/>
               <a:t>The Anthropomorphism Trap</a:t>
             </a:r>
           </a:p>
@@ -14479,7 +14479,7 @@
               <a:buNone/>
             </a:pPr>
             <a:r>
-              <a:rPr lang="en-US" sz="1300"/>
+              <a:rPr lang="en-US" sz="1300" dirty="0"/>
               <a:t>Human-like conversations can trigger emotional attribution.  Users assume intent, feelings, or preferences that don’t exist.</a:t>
             </a:r>
           </a:p>
@@ -14491,7 +14491,7 @@
               <a:buNone/>
             </a:pPr>
             <a:r>
-              <a:rPr lang="en-US" sz="1300" b="1"/>
+              <a:rPr lang="en-US" sz="1300" b="1" dirty="0"/>
               <a:t>Probabilistic vs. Deterministic Thinking</a:t>
             </a:r>
           </a:p>
@@ -14500,7 +14500,7 @@
               <a:buNone/>
             </a:pPr>
             <a:r>
-              <a:rPr lang="en-US" sz="1300"/>
+              <a:rPr lang="en-US" sz="1300" dirty="0"/>
               <a:t>Models generate “likely” responses, not calculated answers.  Each response is a statistical prediction, not a logical deduction.</a:t>
             </a:r>
           </a:p>
@@ -14519,6 +14519,663 @@
   <p:transition>
     <p:fade/>
   </p:transition>
+  <p:timing>
+    <p:tnLst>
+      <p:par>
+        <p:cTn id="1" dur="indefinite" restart="never" nodeType="tmRoot">
+          <p:childTnLst>
+            <p:seq concurrent="1" nextAc="seek">
+              <p:cTn id="2" dur="indefinite" nodeType="mainSeq">
+                <p:childTnLst>
+                  <p:par>
+                    <p:cTn id="3" fill="hold">
+                      <p:stCondLst>
+                        <p:cond delay="indefinite"/>
+                      </p:stCondLst>
+                      <p:childTnLst>
+                        <p:par>
+                          <p:cTn id="4" fill="hold">
+                            <p:stCondLst>
+                              <p:cond delay="0"/>
+                            </p:stCondLst>
+                            <p:childTnLst>
+                              <p:par>
+                                <p:cTn id="5" presetID="10" presetClass="entr" presetSubtype="0" fill="hold" grpId="0" nodeType="clickEffect">
+                                  <p:stCondLst>
+                                    <p:cond delay="0"/>
+                                  </p:stCondLst>
+                                  <p:childTnLst>
+                                    <p:set>
+                                      <p:cBhvr>
+                                        <p:cTn id="6" dur="1" fill="hold">
+                                          <p:stCondLst>
+                                            <p:cond delay="0"/>
+                                          </p:stCondLst>
+                                        </p:cTn>
+                                        <p:tgtEl>
+                                          <p:spTgt spid="4">
+                                            <p:txEl>
+                                              <p:pRg st="0" end="0"/>
+                                            </p:txEl>
+                                          </p:spTgt>
+                                        </p:tgtEl>
+                                        <p:attrNameLst>
+                                          <p:attrName>style.visibility</p:attrName>
+                                        </p:attrNameLst>
+                                      </p:cBhvr>
+                                      <p:to>
+                                        <p:strVal val="visible"/>
+                                      </p:to>
+                                    </p:set>
+                                    <p:animEffect transition="in" filter="fade">
+                                      <p:cBhvr>
+                                        <p:cTn id="7" dur="500"/>
+                                        <p:tgtEl>
+                                          <p:spTgt spid="4">
+                                            <p:txEl>
+                                              <p:pRg st="0" end="0"/>
+                                            </p:txEl>
+                                          </p:spTgt>
+                                        </p:tgtEl>
+                                      </p:cBhvr>
+                                    </p:animEffect>
+                                  </p:childTnLst>
+                                </p:cTn>
+                              </p:par>
+                              <p:par>
+                                <p:cTn id="8" presetID="10" presetClass="entr" presetSubtype="0" fill="hold" grpId="0" nodeType="withEffect">
+                                  <p:stCondLst>
+                                    <p:cond delay="0"/>
+                                  </p:stCondLst>
+                                  <p:childTnLst>
+                                    <p:set>
+                                      <p:cBhvr>
+                                        <p:cTn id="9" dur="1" fill="hold">
+                                          <p:stCondLst>
+                                            <p:cond delay="0"/>
+                                          </p:stCondLst>
+                                        </p:cTn>
+                                        <p:tgtEl>
+                                          <p:spTgt spid="4">
+                                            <p:txEl>
+                                              <p:pRg st="1" end="1"/>
+                                            </p:txEl>
+                                          </p:spTgt>
+                                        </p:tgtEl>
+                                        <p:attrNameLst>
+                                          <p:attrName>style.visibility</p:attrName>
+                                        </p:attrNameLst>
+                                      </p:cBhvr>
+                                      <p:to>
+                                        <p:strVal val="visible"/>
+                                      </p:to>
+                                    </p:set>
+                                    <p:animEffect transition="in" filter="fade">
+                                      <p:cBhvr>
+                                        <p:cTn id="10" dur="500"/>
+                                        <p:tgtEl>
+                                          <p:spTgt spid="4">
+                                            <p:txEl>
+                                              <p:pRg st="1" end="1"/>
+                                            </p:txEl>
+                                          </p:spTgt>
+                                        </p:tgtEl>
+                                      </p:cBhvr>
+                                    </p:animEffect>
+                                  </p:childTnLst>
+                                </p:cTn>
+                              </p:par>
+                            </p:childTnLst>
+                          </p:cTn>
+                        </p:par>
+                      </p:childTnLst>
+                    </p:cTn>
+                  </p:par>
+                  <p:par>
+                    <p:cTn id="11" fill="hold">
+                      <p:stCondLst>
+                        <p:cond delay="indefinite"/>
+                      </p:stCondLst>
+                      <p:childTnLst>
+                        <p:par>
+                          <p:cTn id="12" fill="hold">
+                            <p:stCondLst>
+                              <p:cond delay="0"/>
+                            </p:stCondLst>
+                            <p:childTnLst>
+                              <p:par>
+                                <p:cTn id="13" presetID="10" presetClass="entr" presetSubtype="0" fill="hold" grpId="0" nodeType="clickEffect">
+                                  <p:stCondLst>
+                                    <p:cond delay="0"/>
+                                  </p:stCondLst>
+                                  <p:childTnLst>
+                                    <p:set>
+                                      <p:cBhvr>
+                                        <p:cTn id="14" dur="1" fill="hold">
+                                          <p:stCondLst>
+                                            <p:cond delay="0"/>
+                                          </p:stCondLst>
+                                        </p:cTn>
+                                        <p:tgtEl>
+                                          <p:spTgt spid="4">
+                                            <p:txEl>
+                                              <p:pRg st="2" end="2"/>
+                                            </p:txEl>
+                                          </p:spTgt>
+                                        </p:tgtEl>
+                                        <p:attrNameLst>
+                                          <p:attrName>style.visibility</p:attrName>
+                                        </p:attrNameLst>
+                                      </p:cBhvr>
+                                      <p:to>
+                                        <p:strVal val="visible"/>
+                                      </p:to>
+                                    </p:set>
+                                    <p:animEffect transition="in" filter="fade">
+                                      <p:cBhvr>
+                                        <p:cTn id="15" dur="500"/>
+                                        <p:tgtEl>
+                                          <p:spTgt spid="4">
+                                            <p:txEl>
+                                              <p:pRg st="2" end="2"/>
+                                            </p:txEl>
+                                          </p:spTgt>
+                                        </p:tgtEl>
+                                      </p:cBhvr>
+                                    </p:animEffect>
+                                  </p:childTnLst>
+                                </p:cTn>
+                              </p:par>
+                              <p:par>
+                                <p:cTn id="16" presetID="10" presetClass="entr" presetSubtype="0" fill="hold" grpId="0" nodeType="withEffect">
+                                  <p:stCondLst>
+                                    <p:cond delay="0"/>
+                                  </p:stCondLst>
+                                  <p:childTnLst>
+                                    <p:set>
+                                      <p:cBhvr>
+                                        <p:cTn id="17" dur="1" fill="hold">
+                                          <p:stCondLst>
+                                            <p:cond delay="0"/>
+                                          </p:stCondLst>
+                                        </p:cTn>
+                                        <p:tgtEl>
+                                          <p:spTgt spid="4">
+                                            <p:txEl>
+                                              <p:pRg st="3" end="3"/>
+                                            </p:txEl>
+                                          </p:spTgt>
+                                        </p:tgtEl>
+                                        <p:attrNameLst>
+                                          <p:attrName>style.visibility</p:attrName>
+                                        </p:attrNameLst>
+                                      </p:cBhvr>
+                                      <p:to>
+                                        <p:strVal val="visible"/>
+                                      </p:to>
+                                    </p:set>
+                                    <p:animEffect transition="in" filter="fade">
+                                      <p:cBhvr>
+                                        <p:cTn id="18" dur="500"/>
+                                        <p:tgtEl>
+                                          <p:spTgt spid="4">
+                                            <p:txEl>
+                                              <p:pRg st="3" end="3"/>
+                                            </p:txEl>
+                                          </p:spTgt>
+                                        </p:tgtEl>
+                                      </p:cBhvr>
+                                    </p:animEffect>
+                                  </p:childTnLst>
+                                </p:cTn>
+                              </p:par>
+                            </p:childTnLst>
+                          </p:cTn>
+                        </p:par>
+                      </p:childTnLst>
+                    </p:cTn>
+                  </p:par>
+                  <p:par>
+                    <p:cTn id="19" fill="hold">
+                      <p:stCondLst>
+                        <p:cond delay="indefinite"/>
+                      </p:stCondLst>
+                      <p:childTnLst>
+                        <p:par>
+                          <p:cTn id="20" fill="hold">
+                            <p:stCondLst>
+                              <p:cond delay="0"/>
+                            </p:stCondLst>
+                            <p:childTnLst>
+                              <p:par>
+                                <p:cTn id="21" presetID="10" presetClass="entr" presetSubtype="0" fill="hold" grpId="0" nodeType="clickEffect">
+                                  <p:stCondLst>
+                                    <p:cond delay="0"/>
+                                  </p:stCondLst>
+                                  <p:childTnLst>
+                                    <p:set>
+                                      <p:cBhvr>
+                                        <p:cTn id="22" dur="1" fill="hold">
+                                          <p:stCondLst>
+                                            <p:cond delay="0"/>
+                                          </p:stCondLst>
+                                        </p:cTn>
+                                        <p:tgtEl>
+                                          <p:spTgt spid="4">
+                                            <p:txEl>
+                                              <p:pRg st="4" end="4"/>
+                                            </p:txEl>
+                                          </p:spTgt>
+                                        </p:tgtEl>
+                                        <p:attrNameLst>
+                                          <p:attrName>style.visibility</p:attrName>
+                                        </p:attrNameLst>
+                                      </p:cBhvr>
+                                      <p:to>
+                                        <p:strVal val="visible"/>
+                                      </p:to>
+                                    </p:set>
+                                    <p:animEffect transition="in" filter="fade">
+                                      <p:cBhvr>
+                                        <p:cTn id="23" dur="500"/>
+                                        <p:tgtEl>
+                                          <p:spTgt spid="4">
+                                            <p:txEl>
+                                              <p:pRg st="4" end="4"/>
+                                            </p:txEl>
+                                          </p:spTgt>
+                                        </p:tgtEl>
+                                      </p:cBhvr>
+                                    </p:animEffect>
+                                  </p:childTnLst>
+                                </p:cTn>
+                              </p:par>
+                              <p:par>
+                                <p:cTn id="24" presetID="10" presetClass="entr" presetSubtype="0" fill="hold" grpId="0" nodeType="withEffect">
+                                  <p:stCondLst>
+                                    <p:cond delay="0"/>
+                                  </p:stCondLst>
+                                  <p:childTnLst>
+                                    <p:set>
+                                      <p:cBhvr>
+                                        <p:cTn id="25" dur="1" fill="hold">
+                                          <p:stCondLst>
+                                            <p:cond delay="0"/>
+                                          </p:stCondLst>
+                                        </p:cTn>
+                                        <p:tgtEl>
+                                          <p:spTgt spid="4">
+                                            <p:txEl>
+                                              <p:pRg st="5" end="5"/>
+                                            </p:txEl>
+                                          </p:spTgt>
+                                        </p:tgtEl>
+                                        <p:attrNameLst>
+                                          <p:attrName>style.visibility</p:attrName>
+                                        </p:attrNameLst>
+                                      </p:cBhvr>
+                                      <p:to>
+                                        <p:strVal val="visible"/>
+                                      </p:to>
+                                    </p:set>
+                                    <p:animEffect transition="in" filter="fade">
+                                      <p:cBhvr>
+                                        <p:cTn id="26" dur="500"/>
+                                        <p:tgtEl>
+                                          <p:spTgt spid="4">
+                                            <p:txEl>
+                                              <p:pRg st="5" end="5"/>
+                                            </p:txEl>
+                                          </p:spTgt>
+                                        </p:tgtEl>
+                                      </p:cBhvr>
+                                    </p:animEffect>
+                                  </p:childTnLst>
+                                </p:cTn>
+                              </p:par>
+                            </p:childTnLst>
+                          </p:cTn>
+                        </p:par>
+                      </p:childTnLst>
+                    </p:cTn>
+                  </p:par>
+                  <p:par>
+                    <p:cTn id="27" fill="hold">
+                      <p:stCondLst>
+                        <p:cond delay="indefinite"/>
+                      </p:stCondLst>
+                      <p:childTnLst>
+                        <p:par>
+                          <p:cTn id="28" fill="hold">
+                            <p:stCondLst>
+                              <p:cond delay="0"/>
+                            </p:stCondLst>
+                            <p:childTnLst>
+                              <p:par>
+                                <p:cTn id="29" presetID="10" presetClass="entr" presetSubtype="0" fill="hold" grpId="0" nodeType="clickEffect">
+                                  <p:stCondLst>
+                                    <p:cond delay="0"/>
+                                  </p:stCondLst>
+                                  <p:childTnLst>
+                                    <p:set>
+                                      <p:cBhvr>
+                                        <p:cTn id="30" dur="1" fill="hold">
+                                          <p:stCondLst>
+                                            <p:cond delay="0"/>
+                                          </p:stCondLst>
+                                        </p:cTn>
+                                        <p:tgtEl>
+                                          <p:spTgt spid="4">
+                                            <p:txEl>
+                                              <p:pRg st="6" end="6"/>
+                                            </p:txEl>
+                                          </p:spTgt>
+                                        </p:tgtEl>
+                                        <p:attrNameLst>
+                                          <p:attrName>style.visibility</p:attrName>
+                                        </p:attrNameLst>
+                                      </p:cBhvr>
+                                      <p:to>
+                                        <p:strVal val="visible"/>
+                                      </p:to>
+                                    </p:set>
+                                    <p:animEffect transition="in" filter="fade">
+                                      <p:cBhvr>
+                                        <p:cTn id="31" dur="500"/>
+                                        <p:tgtEl>
+                                          <p:spTgt spid="4">
+                                            <p:txEl>
+                                              <p:pRg st="6" end="6"/>
+                                            </p:txEl>
+                                          </p:spTgt>
+                                        </p:tgtEl>
+                                      </p:cBhvr>
+                                    </p:animEffect>
+                                  </p:childTnLst>
+                                </p:cTn>
+                              </p:par>
+                              <p:par>
+                                <p:cTn id="32" presetID="10" presetClass="entr" presetSubtype="0" fill="hold" grpId="0" nodeType="withEffect">
+                                  <p:stCondLst>
+                                    <p:cond delay="0"/>
+                                  </p:stCondLst>
+                                  <p:childTnLst>
+                                    <p:set>
+                                      <p:cBhvr>
+                                        <p:cTn id="33" dur="1" fill="hold">
+                                          <p:stCondLst>
+                                            <p:cond delay="0"/>
+                                          </p:stCondLst>
+                                        </p:cTn>
+                                        <p:tgtEl>
+                                          <p:spTgt spid="4">
+                                            <p:txEl>
+                                              <p:pRg st="7" end="7"/>
+                                            </p:txEl>
+                                          </p:spTgt>
+                                        </p:tgtEl>
+                                        <p:attrNameLst>
+                                          <p:attrName>style.visibility</p:attrName>
+                                        </p:attrNameLst>
+                                      </p:cBhvr>
+                                      <p:to>
+                                        <p:strVal val="visible"/>
+                                      </p:to>
+                                    </p:set>
+                                    <p:animEffect transition="in" filter="fade">
+                                      <p:cBhvr>
+                                        <p:cTn id="34" dur="500"/>
+                                        <p:tgtEl>
+                                          <p:spTgt spid="4">
+                                            <p:txEl>
+                                              <p:pRg st="7" end="7"/>
+                                            </p:txEl>
+                                          </p:spTgt>
+                                        </p:tgtEl>
+                                      </p:cBhvr>
+                                    </p:animEffect>
+                                  </p:childTnLst>
+                                </p:cTn>
+                              </p:par>
+                            </p:childTnLst>
+                          </p:cTn>
+                        </p:par>
+                      </p:childTnLst>
+                    </p:cTn>
+                  </p:par>
+                  <p:par>
+                    <p:cTn id="35" fill="hold">
+                      <p:stCondLst>
+                        <p:cond delay="indefinite"/>
+                      </p:stCondLst>
+                      <p:childTnLst>
+                        <p:par>
+                          <p:cTn id="36" fill="hold">
+                            <p:stCondLst>
+                              <p:cond delay="0"/>
+                            </p:stCondLst>
+                            <p:childTnLst>
+                              <p:par>
+                                <p:cTn id="37" presetID="10" presetClass="entr" presetSubtype="0" fill="hold" grpId="0" nodeType="clickEffect">
+                                  <p:stCondLst>
+                                    <p:cond delay="0"/>
+                                  </p:stCondLst>
+                                  <p:childTnLst>
+                                    <p:set>
+                                      <p:cBhvr>
+                                        <p:cTn id="38" dur="1" fill="hold">
+                                          <p:stCondLst>
+                                            <p:cond delay="0"/>
+                                          </p:stCondLst>
+                                        </p:cTn>
+                                        <p:tgtEl>
+                                          <p:spTgt spid="4">
+                                            <p:txEl>
+                                              <p:pRg st="8" end="8"/>
+                                            </p:txEl>
+                                          </p:spTgt>
+                                        </p:tgtEl>
+                                        <p:attrNameLst>
+                                          <p:attrName>style.visibility</p:attrName>
+                                        </p:attrNameLst>
+                                      </p:cBhvr>
+                                      <p:to>
+                                        <p:strVal val="visible"/>
+                                      </p:to>
+                                    </p:set>
+                                    <p:animEffect transition="in" filter="fade">
+                                      <p:cBhvr>
+                                        <p:cTn id="39" dur="500"/>
+                                        <p:tgtEl>
+                                          <p:spTgt spid="4">
+                                            <p:txEl>
+                                              <p:pRg st="8" end="8"/>
+                                            </p:txEl>
+                                          </p:spTgt>
+                                        </p:tgtEl>
+                                      </p:cBhvr>
+                                    </p:animEffect>
+                                  </p:childTnLst>
+                                </p:cTn>
+                              </p:par>
+                              <p:par>
+                                <p:cTn id="40" presetID="10" presetClass="entr" presetSubtype="0" fill="hold" grpId="0" nodeType="withEffect">
+                                  <p:stCondLst>
+                                    <p:cond delay="0"/>
+                                  </p:stCondLst>
+                                  <p:childTnLst>
+                                    <p:set>
+                                      <p:cBhvr>
+                                        <p:cTn id="41" dur="1" fill="hold">
+                                          <p:stCondLst>
+                                            <p:cond delay="0"/>
+                                          </p:stCondLst>
+                                        </p:cTn>
+                                        <p:tgtEl>
+                                          <p:spTgt spid="4">
+                                            <p:txEl>
+                                              <p:pRg st="9" end="9"/>
+                                            </p:txEl>
+                                          </p:spTgt>
+                                        </p:tgtEl>
+                                        <p:attrNameLst>
+                                          <p:attrName>style.visibility</p:attrName>
+                                        </p:attrNameLst>
+                                      </p:cBhvr>
+                                      <p:to>
+                                        <p:strVal val="visible"/>
+                                      </p:to>
+                                    </p:set>
+                                    <p:animEffect transition="in" filter="fade">
+                                      <p:cBhvr>
+                                        <p:cTn id="42" dur="500"/>
+                                        <p:tgtEl>
+                                          <p:spTgt spid="4">
+                                            <p:txEl>
+                                              <p:pRg st="9" end="9"/>
+                                            </p:txEl>
+                                          </p:spTgt>
+                                        </p:tgtEl>
+                                      </p:cBhvr>
+                                    </p:animEffect>
+                                  </p:childTnLst>
+                                </p:cTn>
+                              </p:par>
+                            </p:childTnLst>
+                          </p:cTn>
+                        </p:par>
+                      </p:childTnLst>
+                    </p:cTn>
+                  </p:par>
+                  <p:par>
+                    <p:cTn id="43" fill="hold">
+                      <p:stCondLst>
+                        <p:cond delay="indefinite"/>
+                      </p:stCondLst>
+                      <p:childTnLst>
+                        <p:par>
+                          <p:cTn id="44" fill="hold">
+                            <p:stCondLst>
+                              <p:cond delay="0"/>
+                            </p:stCondLst>
+                            <p:childTnLst>
+                              <p:par>
+                                <p:cTn id="45" presetID="10" presetClass="entr" presetSubtype="0" fill="hold" grpId="0" nodeType="clickEffect">
+                                  <p:stCondLst>
+                                    <p:cond delay="0"/>
+                                  </p:stCondLst>
+                                  <p:childTnLst>
+                                    <p:set>
+                                      <p:cBhvr>
+                                        <p:cTn id="46" dur="1" fill="hold">
+                                          <p:stCondLst>
+                                            <p:cond delay="0"/>
+                                          </p:stCondLst>
+                                        </p:cTn>
+                                        <p:tgtEl>
+                                          <p:spTgt spid="4">
+                                            <p:txEl>
+                                              <p:pRg st="10" end="10"/>
+                                            </p:txEl>
+                                          </p:spTgt>
+                                        </p:tgtEl>
+                                        <p:attrNameLst>
+                                          <p:attrName>style.visibility</p:attrName>
+                                        </p:attrNameLst>
+                                      </p:cBhvr>
+                                      <p:to>
+                                        <p:strVal val="visible"/>
+                                      </p:to>
+                                    </p:set>
+                                    <p:animEffect transition="in" filter="fade">
+                                      <p:cBhvr>
+                                        <p:cTn id="47" dur="500"/>
+                                        <p:tgtEl>
+                                          <p:spTgt spid="4">
+                                            <p:txEl>
+                                              <p:pRg st="10" end="10"/>
+                                            </p:txEl>
+                                          </p:spTgt>
+                                        </p:tgtEl>
+                                      </p:cBhvr>
+                                    </p:animEffect>
+                                  </p:childTnLst>
+                                </p:cTn>
+                              </p:par>
+                              <p:par>
+                                <p:cTn id="48" presetID="10" presetClass="entr" presetSubtype="0" fill="hold" grpId="0" nodeType="withEffect">
+                                  <p:stCondLst>
+                                    <p:cond delay="0"/>
+                                  </p:stCondLst>
+                                  <p:childTnLst>
+                                    <p:set>
+                                      <p:cBhvr>
+                                        <p:cTn id="49" dur="1" fill="hold">
+                                          <p:stCondLst>
+                                            <p:cond delay="0"/>
+                                          </p:stCondLst>
+                                        </p:cTn>
+                                        <p:tgtEl>
+                                          <p:spTgt spid="4">
+                                            <p:txEl>
+                                              <p:pRg st="11" end="11"/>
+                                            </p:txEl>
+                                          </p:spTgt>
+                                        </p:tgtEl>
+                                        <p:attrNameLst>
+                                          <p:attrName>style.visibility</p:attrName>
+                                        </p:attrNameLst>
+                                      </p:cBhvr>
+                                      <p:to>
+                                        <p:strVal val="visible"/>
+                                      </p:to>
+                                    </p:set>
+                                    <p:animEffect transition="in" filter="fade">
+                                      <p:cBhvr>
+                                        <p:cTn id="50" dur="500"/>
+                                        <p:tgtEl>
+                                          <p:spTgt spid="4">
+                                            <p:txEl>
+                                              <p:pRg st="11" end="11"/>
+                                            </p:txEl>
+                                          </p:spTgt>
+                                        </p:tgtEl>
+                                      </p:cBhvr>
+                                    </p:animEffect>
+                                  </p:childTnLst>
+                                </p:cTn>
+                              </p:par>
+                            </p:childTnLst>
+                          </p:cTn>
+                        </p:par>
+                      </p:childTnLst>
+                    </p:cTn>
+                  </p:par>
+                </p:childTnLst>
+              </p:cTn>
+              <p:prevCondLst>
+                <p:cond evt="onPrev" delay="0">
+                  <p:tgtEl>
+                    <p:sldTgt/>
+                  </p:tgtEl>
+                </p:cond>
+              </p:prevCondLst>
+              <p:nextCondLst>
+                <p:cond evt="onNext" delay="0">
+                  <p:tgtEl>
+                    <p:sldTgt/>
+                  </p:tgtEl>
+                </p:cond>
+              </p:nextCondLst>
+            </p:seq>
+          </p:childTnLst>
+        </p:cTn>
+      </p:par>
+    </p:tnLst>
+    <p:bldLst>
+      <p:bldP spid="4" grpId="0" build="p"/>
+    </p:bldLst>
+  </p:timing>
 </p:sld>
 </file>
 

</xml_diff>